<commit_message>
Section learning outcomes rewritten as capability statements, Units 2 to 12
Co-Authored-By: Claude Opus 5.5 <noreply@anthropic.com>
</commit_message>
<xml_diff>
--- a/Unit decks/Unit 02 - Strategy Visioning & Success in Practice (SiP).pptx
+++ b/Unit decks/Unit 02 - Strategy Visioning & Success in Practice (SiP).pptx
@@ -827,7 +827,7 @@
           <a:p>
             <a:r>
               <a:rPr lang="en-US" dirty="0"/>
-              <a:t>1. Explain how a shared strategic ambition and a shared picture of success keep leaders and functions aligned.</a:t>
+              <a:t>1. Align leaders and functions around a shared strategic ambition and a shared picture of success.</a:t>
             </a:r>
           </a:p>
           <a:p>
@@ -9948,14 +9948,14 @@
           <a:p>
             <a:r>
               <a:rPr lang="en-US" b="1" dirty="0"/>
-              <a:t>SECTION LEARNING OUTCOMES:</a:t>
-            </a:r>
-            <a:r>
-              <a:rPr lang="en-US" dirty="0"/>
-              <a:t>
-1. Redefine strategy to create a robust understanding of strategy architecture.
+              <a:t>SECTION LEARNING OUTCOMES:
+1. Define strategy through the architecture that connects direction to success.
 2. Distinguish the direction an organisation sets from the future position that defines its success.
 </a:t>
+            </a:r>
+            <a:r>
+              <a:rPr lang="en-US" dirty="0"/>
+              <a:t/>
             </a:r>
           </a:p>
           <a:p>
@@ -13856,7 +13856,7 @@
                 <a:ea typeface="Calibri" pitchFamily="34" charset="-122"/>
                 <a:cs typeface="Calibri" pitchFamily="34" charset="-120"/>
               </a:rPr>
-              <a:t>Explain how a shared strategic ambition and a shared picture of success keep leaders and functions aligned.</a:t>
+              <a:t>Align leaders and functions around a shared strategic ambition and a shared picture of success.</a:t>
             </a:r>
             <a:endParaRPr lang="en-US" sz="2400" dirty="0"/>
           </a:p>
@@ -30919,7 +30919,7 @@
                 <a:ea typeface="Calibri" pitchFamily="34" charset="-122"/>
                 <a:cs typeface="Calibri" pitchFamily="34" charset="-120"/>
               </a:rPr>
-              <a:t>Redefine strategy to create a robust understanding of strategy architecture.</a:t>
+              <a:t>Define strategy through the architecture that connects direction to success.</a:t>
             </a:r>
             <a:endParaRPr lang="en-US" sz="2400" dirty="0"/>
           </a:p>

</xml_diff>

<commit_message>
Units 2-9 consistency: 12 Oct hygiene live, people/organisational performance from Unit 6 to 9, rule fixes, decks and reflection slides
Co-Authored-By: Claude Opus 5.5 <noreply@anthropic.com>

Claude-Session: https://claude.ai/code/session_01NZNfaSjfMo2vQpEBM1Wf8m
</commit_message>
<xml_diff>
--- a/Unit decks/Unit 02 - Strategy Visioning & Success in Practice (SiP).pptx
+++ b/Unit decks/Unit 02 - Strategy Visioning & Success in Practice (SiP).pptx
@@ -1086,7 +1086,7 @@
           <a:p>
             <a:r>
               <a:rPr lang="en-US" b="1" dirty="0"/>
-              <a:t>3. Leave one question in the room.</a:t>
+              <a:t>3. Leave one question with the group.</a:t>
             </a:r>
           </a:p>
           <a:p>
@@ -2203,7 +2203,7 @@
           <a:p>
             <a:r>
               <a:rPr lang="en-US" dirty="0"/>
-              <a:t>Take a show of hands for each function and say what the pattern in the room is.</a:t>
+              <a:t>Take a show of hands for each function and say what pattern the group shows.</a:t>
             </a:r>
           </a:p>
           <a:p>
@@ -10451,7 +10451,7 @@
           <a:p>
             <a:r>
               <a:rPr lang="en-US" b="1" dirty="0"/>
-              <a:t>5. Leave one question in the room.</a:t>
+              <a:t>5. Leave one question with the group.</a:t>
             </a:r>
           </a:p>
           <a:p>
@@ -12210,7 +12210,7 @@
           <a:p>
             <a:r>
               <a:rPr lang="en-US" dirty="0"/>
-              <a:t>Take a show of hands for each dimension and say what the pattern in the room is. </a:t>
+              <a:t>Take a show of hands for each dimension and say what pattern the group shows. </a:t>
             </a:r>
           </a:p>
           <a:p>
@@ -27625,7 +27625,7 @@
                 <a:ea typeface="Cambria" pitchFamily="34" charset="-122"/>
                 <a:cs typeface="Cambria" pitchFamily="34" charset="-120"/>
               </a:rPr>
-              <a:t>4.3 Step 3: Build Success in Practice</a:t>
+              <a:t>4.3 · Step 3: Build Success in Practice</a:t>
             </a:r>
             <a:endParaRPr lang="en-US" sz="3600" dirty="0"/>
           </a:p>
@@ -29436,7 +29436,7 @@
                 <a:ea typeface="Cambria" pitchFamily="34" charset="-122"/>
                 <a:cs typeface="Cambria" pitchFamily="34" charset="-120"/>
               </a:rPr>
-              <a:t>5.1 Role Contribution to SiP</a:t>
+              <a:t>5.1 · Role Contribution to SiP</a:t>
             </a:r>
             <a:endParaRPr lang="en-US" sz="3600" dirty="0"/>
           </a:p>
@@ -31420,7 +31420,7 @@
                 <a:ea typeface="Cambria" pitchFamily="34" charset="-122"/>
                 <a:cs typeface="Cambria" pitchFamily="34" charset="-120"/>
               </a:rPr>
-              <a:t>1.1· Building the Strategy Architecture</a:t>
+              <a:t>1.1 · Building the Strategy Architecture</a:t>
             </a:r>
             <a:endParaRPr lang="en-US" sz="3600" dirty="0"/>
           </a:p>
@@ -33263,7 +33263,7 @@
                 <a:ea typeface="Cambria" pitchFamily="34" charset="-122"/>
                 <a:cs typeface="Cambria" pitchFamily="34" charset="-120"/>
               </a:rPr>
-              <a:t>1.3 · Defining the Success In Practice</a:t>
+              <a:t>1.3 · Defining the Success in Practice</a:t>
             </a:r>
             <a:endParaRPr lang="en-US" sz="3600" dirty="0"/>
           </a:p>

</xml_diff>

<commit_message>
Units 2-9: Carol's capability learning outcomes on pages, decks and notes
Co-Authored-By: Claude Opus 5.5 <noreply@anthropic.com>

Claude-Session: https://claude.ai/code/session_01NZNfaSjfMo2vQpEBM1Wf8m
</commit_message>
<xml_diff>
--- a/Unit decks/Unit 02 - Strategy Visioning & Success in Practice (SiP).pptx
+++ b/Unit decks/Unit 02 - Strategy Visioning & Success in Practice (SiP).pptx
@@ -827,21 +827,21 @@
           <a:p>
             <a:r>
               <a:rPr lang="en-US" dirty="0"/>
-              <a:t>1. Align leaders and functions around a shared strategic ambition and a shared picture of success.</a:t>
-            </a:r>
-          </a:p>
-          <a:p>
-            <a:r>
-              <a:rPr lang="en-US" dirty="0"/>
-              <a:t>2. </a:t>
+              <a:t>1. Reconcile leadership perspectives into a shared strategic ambition and picture of success.</a:t>
+            </a:r>
+          </a:p>
+          <a:p>
+            <a:r>
+              <a:rPr lang="en-US" dirty="0"/>
+              <a:t>2. Apply strategic direction as a consistent basis for enterprise decisions.</a:t>
             </a:r>
             <a:r>
               <a:rPr lang="en-US" dirty="0" err="1"/>
-              <a:t>Recognise</a:t>
-            </a:r>
-            <a:r>
-              <a:rPr lang="en-US" dirty="0"/>
-              <a:t> how a shared direction filters decisions throughout execution.</a:t>
+              <a:t/>
+            </a:r>
+            <a:r>
+              <a:rPr lang="en-US" dirty="0"/>
+              <a:t/>
             </a:r>
           </a:p>
           <a:p>
@@ -2356,21 +2356,21 @@
           <a:p>
             <a:r>
               <a:rPr lang="en-US" dirty="0"/>
-              <a:t>1. Use observable indicators to examine what success looks like within each of the four </a:t>
+              <a:t>1. Specify observable evidence of success across the four SiP domains.</a:t>
             </a:r>
             <a:r>
               <a:rPr lang="en-US" dirty="0" err="1"/>
-              <a:t>SiP</a:t>
-            </a:r>
-            <a:r>
-              <a:rPr lang="en-US" dirty="0"/>
-              <a:t> domains.</a:t>
-            </a:r>
-          </a:p>
-          <a:p>
-            <a:r>
-              <a:rPr lang="en-US" dirty="0"/>
-              <a:t>2. Distinguish between conditions that demonstrate success and signals that those conditions are absent.</a:t>
+              <a:t/>
+            </a:r>
+            <a:r>
+              <a:rPr lang="en-US" dirty="0"/>
+              <a:t/>
+            </a:r>
+          </a:p>
+          <a:p>
+            <a:r>
+              <a:rPr lang="en-US" dirty="0"/>
+              <a:t>2. Interpret gaps between intended success and current conditions to identify strategic misalignment.</a:t>
             </a:r>
           </a:p>
           <a:p>
@@ -5954,13 +5954,13 @@
           <a:p>
             <a:r>
               <a:rPr lang="en-US" dirty="0"/>
-              <a:t>1. Build a coherent Strategy Architecture.</a:t>
-            </a:r>
-          </a:p>
-          <a:p>
-            <a:r>
-              <a:rPr lang="en-US" dirty="0"/>
-              <a:t>2. Integrate different leadership perspectives into one shared enterprise position.</a:t>
+              <a:t>1. Integrate the elements of Strategy Architecture into a coherent enterprise strategy.</a:t>
+            </a:r>
+          </a:p>
+          <a:p>
+            <a:r>
+              <a:rPr lang="en-US" dirty="0"/>
+              <a:t>2. Synthesise diverse leadership perspectives into an agreed enterprise position.</a:t>
             </a:r>
           </a:p>
           <a:p>
@@ -8643,13 +8643,13 @@
           <a:p>
             <a:r>
               <a:rPr lang="en-US" dirty="0"/>
-              <a:t>1. Apply the agreed Success in Practice to specific executive roles.</a:t>
-            </a:r>
-          </a:p>
-          <a:p>
-            <a:r>
-              <a:rPr lang="en-US" dirty="0"/>
-              <a:t>2. Define what each leadership role must contribute to make the Strategy Intent real.</a:t>
+              <a:t>1. Translate Success in Practice into clear executive contribution expectations.</a:t>
+            </a:r>
+          </a:p>
+          <a:p>
+            <a:r>
+              <a:rPr lang="en-US" dirty="0"/>
+              <a:t>2. Coordinate leadership contributions required to realise strategic intent.</a:t>
             </a:r>
           </a:p>
           <a:p>
@@ -9949,8 +9949,8 @@
             <a:r>
               <a:rPr lang="en-US" b="1" dirty="0"/>
               <a:t>SECTION LEARNING OUTCOMES:
-1. Define strategy through the architecture that connects direction to success.
-2. Distinguish the direction an organisation sets from the future position that defines its success.
+1. Frame strategic direction in terms of the value and success the organisation intends to create.
+2. Differentiate strategic direction from the future position it seeks while maintaining coherence between them.
 </a:t>
             </a:r>
             <a:r>
@@ -13856,7 +13856,7 @@
                 <a:ea typeface="Calibri" pitchFamily="34" charset="-122"/>
                 <a:cs typeface="Calibri" pitchFamily="34" charset="-120"/>
               </a:rPr>
-              <a:t>Align leaders and functions around a shared strategic ambition and a shared picture of success.</a:t>
+              <a:t>Reconcile leadership perspectives into a shared strategic ambition and picture of success.</a:t>
             </a:r>
             <a:endParaRPr lang="en-US" sz="2400" dirty="0"/>
           </a:p>
@@ -13951,7 +13951,7 @@
                 <a:ea typeface="Calibri" pitchFamily="34" charset="-122"/>
                 <a:cs typeface="Calibri" pitchFamily="34" charset="-120"/>
               </a:rPr>
-              <a:t>Recognise how a shared direction filters decisions throughout execution.</a:t>
+              <a:t>Apply strategic direction as a consistent basis for enterprise decisions.</a:t>
             </a:r>
             <a:endParaRPr lang="en-US" sz="2400" dirty="0"/>
           </a:p>
@@ -16901,7 +16901,7 @@
                 <a:ea typeface="Calibri" pitchFamily="34" charset="-122"/>
                 <a:cs typeface="Calibri" pitchFamily="34" charset="-120"/>
               </a:rPr>
-              <a:t>Use observable indicators to examine what success looks like within each of the four SiP domains.</a:t>
+              <a:t>Specify observable evidence of success across the four SiP domains.</a:t>
             </a:r>
             <a:endParaRPr lang="en-US" sz="2400" dirty="0"/>
           </a:p>
@@ -16996,7 +16996,7 @@
                 <a:ea typeface="Calibri" pitchFamily="34" charset="-122"/>
                 <a:cs typeface="Calibri" pitchFamily="34" charset="-120"/>
               </a:rPr>
-              <a:t>Distinguish between conditions that demonstrate success and signals that those conditions are absent.</a:t>
+              <a:t>Interpret gaps between intended success and current conditions to identify strategic misalignment.</a:t>
             </a:r>
             <a:endParaRPr lang="en-US" sz="2400" dirty="0"/>
           </a:p>
@@ -18476,7 +18476,7 @@
                 <a:ea typeface="Calibri" pitchFamily="34" charset="-122"/>
                 <a:cs typeface="Calibri" pitchFamily="34" charset="-120"/>
               </a:rPr>
-              <a:t>Define strategy architecture and articulate strategic intent in relation to the organisation’s purpose, long-term value and stakeholder relevance.</a:t>
+              <a:t>Design a coherent strategic direction that connects organisational purpose, stakeholder value and long-term ambition.</a:t>
             </a:r>
             <a:endParaRPr lang="en-US" sz="2400" dirty="0"/>
           </a:p>
@@ -18571,7 +18571,7 @@
                 <a:ea typeface="Calibri" pitchFamily="34" charset="-122"/>
                 <a:cs typeface="Calibri" pitchFamily="34" charset="-120"/>
               </a:rPr>
-              <a:t>Define a coherent future position and the organisational meaning of success.</a:t>
+              <a:t>Articulate a shared future position and define what organisational success will look like in practice.</a:t>
             </a:r>
             <a:endParaRPr lang="en-US" sz="2400" dirty="0"/>
           </a:p>
@@ -18666,7 +18666,7 @@
                 <a:ea typeface="Calibri" pitchFamily="34" charset="-122"/>
                 <a:cs typeface="Calibri" pitchFamily="34" charset="-120"/>
               </a:rPr>
-              <a:t>Evaluate the consistency between strategic ambition, organisational identity and the realities of the operating environment.</a:t>
+              <a:t>Test strategic ambition against organisational identity and operating realities to strengthen its feasibility.</a:t>
             </a:r>
             <a:endParaRPr lang="en-US" sz="2400" dirty="0"/>
           </a:p>
@@ -18761,7 +18761,7 @@
                 <a:ea typeface="Calibri" pitchFamily="34" charset="-122"/>
                 <a:cs typeface="Calibri" pitchFamily="34" charset="-120"/>
               </a:rPr>
-              <a:t>Establish a shared strategic direction that supports consistent enterprise interpretation and decision-making.</a:t>
+              <a:t>Align enterprise decisions and leadership interpretation around a common strategic direction.</a:t>
             </a:r>
             <a:endParaRPr lang="en-US" sz="2400" dirty="0"/>
           </a:p>
@@ -22211,7 +22211,7 @@
                 <a:ea typeface="Calibri" pitchFamily="34" charset="-122"/>
                 <a:cs typeface="Calibri" pitchFamily="34" charset="-120"/>
               </a:rPr>
-              <a:t>Build a coherent Strategy Architecture.</a:t>
+              <a:t>Integrate the elements of Strategy Architecture into a coherent enterprise strategy.</a:t>
             </a:r>
             <a:endParaRPr lang="en-US" sz="2400" dirty="0"/>
           </a:p>
@@ -22306,7 +22306,7 @@
                 <a:ea typeface="Calibri" pitchFamily="34" charset="-122"/>
                 <a:cs typeface="Calibri" pitchFamily="34" charset="-120"/>
               </a:rPr>
-              <a:t>Integrate different leadership perspectives into one shared enterprise position.</a:t>
+              <a:t>Synthesise diverse leadership perspectives into an agreed enterprise position.</a:t>
             </a:r>
             <a:endParaRPr lang="en-US" sz="2400" dirty="0"/>
           </a:p>
@@ -29269,7 +29269,7 @@
                 <a:ea typeface="Calibri" pitchFamily="34" charset="-122"/>
                 <a:cs typeface="Calibri" pitchFamily="34" charset="-120"/>
               </a:rPr>
-              <a:t>Apply the agreed Success in Practice to specific executive roles.</a:t>
+              <a:t>Translate Success in Practice into clear executive contribution expectations.</a:t>
             </a:r>
             <a:endParaRPr lang="en-US" sz="2400" dirty="0"/>
           </a:p>
@@ -29364,7 +29364,7 @@
                 <a:ea typeface="Calibri" pitchFamily="34" charset="-122"/>
                 <a:cs typeface="Calibri" pitchFamily="34" charset="-120"/>
               </a:rPr>
-              <a:t>Define what each leadership role must contribute to make the Strategy Intent real.</a:t>
+              <a:t>Coordinate leadership contributions required to realise strategic intent.</a:t>
             </a:r>
             <a:endParaRPr lang="en-US" sz="2400" dirty="0"/>
           </a:p>
@@ -30919,7 +30919,7 @@
                 <a:ea typeface="Calibri" pitchFamily="34" charset="-122"/>
                 <a:cs typeface="Calibri" pitchFamily="34" charset="-120"/>
               </a:rPr>
-              <a:t>Define strategy through the architecture that connects direction to success.</a:t>
+              <a:t>Frame strategic direction in terms of the value and success the organisation intends to create.</a:t>
             </a:r>
             <a:endParaRPr lang="en-US" sz="2400" dirty="0"/>
           </a:p>
@@ -31014,7 +31014,7 @@
                 <a:ea typeface="Calibri" pitchFamily="34" charset="-122"/>
                 <a:cs typeface="Calibri" pitchFamily="34" charset="-120"/>
               </a:rPr>
-              <a:t>Distinguish the direction an organisation sets from the future position that defines its success.</a:t>
+              <a:t>Differentiate strategic direction from the future position it seeks while maintaining coherence between them.</a:t>
             </a:r>
             <a:endParaRPr lang="en-US" sz="2400" dirty="0"/>
           </a:p>

</xml_diff>

<commit_message>
Capstone S2R Blueprint name everywhere; admin attendance and missed-session check-ins
Co-Authored-By: Claude Opus 5.5 <noreply@anthropic.com>

Claude-Session: https://claude.ai/code/session_01MS4vYdUfXHr5vaRrfWjeLk
</commit_message>
<xml_diff>
--- a/Unit decks/Unit 02 - Strategy Visioning & Success in Practice (SiP).pptx
+++ b/Unit decks/Unit 02 - Strategy Visioning & Success in Practice (SiP).pptx
@@ -440,7 +440,7 @@
           </a:p>
           <a:p>
             <a:r>
-              <a:t>- When every member has agreed, the three outputs feed the team's Capstone Blueprint, boxes 2A to 2F.</a:t>
+              <a:t>- When every member has agreed, the three outputs feed the team's Capstone S2R Blueprint, boxes 2A to 2F.</a:t>
             </a:r>
           </a:p>
           <a:p/>
@@ -8162,7 +8162,7 @@
           </a:p>
           <a:p>
             <a:r>
-              <a:t>When every member has agreed, the three outputs go into your team's Capstone Blueprint. If the scribe changes an entry after that, the agreements clear and every member agrees again."</a:t>
+              <a:t>When every member has agreed, the three outputs go into your team's Capstone S2R Blueprint. If the scribe changes an entry after that, the agreements clear and every member agrees again."</a:t>
             </a:r>
           </a:p>
           <a:p/>
@@ -8191,7 +8191,7 @@
           </a:p>
           <a:p>
             <a:r>
-              <a:t>The group chooses its scribe in 5.1 of the participant file and builds the three steps. Each member reads the Group record and selects Agree. The three outputs feed boxes 2A to 2F of the team's Capstone Blueprint.</a:t>
+              <a:t>The group chooses its scribe in 5.1 of the participant file and builds the three steps. Each member reads the Group record and selects Agree. The three outputs feed boxes 2A to 2F of the team's Capstone S2R Blueprint.</a:t>
             </a:r>
           </a:p>
         </p:txBody>
@@ -8644,7 +8644,7 @@
           </a:p>
           <a:p>
             <a:r>
-              <a:t>Each group built the same three outputs for its own simulated company. Every member agreed the group record, and the three outputs went into the team's Capstone Blueprint.</a:t>
+              <a:t>Each group built the same three outputs for its own simulated company. Every member agreed the group record, and the three outputs went into the team's Capstone S2R Blueprint.</a:t>
             </a:r>
           </a:p>
           <a:p>

</xml_diff>

<commit_message>
Unit decks clean-up: no overlapping text, detailed notes for all units, Units 10-12 rebuilt
</commit_message>
<xml_diff>
--- a/Unit decks/Unit 02 - Strategy Visioning & Success in Practice (SiP).pptx
+++ b/Unit decks/Unit 02 - Strategy Visioning & Success in Practice (SiP).pptx
@@ -2001,7 +2001,7 @@
             </a:r>
             <a:r>
               <a:rPr lang="en-US" dirty="0"/>
-              <a:t>"Section 5 puts this function to work: each of you defines what one executive role must contribute so that the agreed Success in Practice becomes real."</a:t>
+              <a:t>"Section 5 puts this function to work: your group builds one Strategy Intent and one Success in Practice that every function in your company can read its contribution against."</a:t>
             </a:r>
           </a:p>
           <a:p>
@@ -2463,7 +2463,7 @@
           <a:p>
             <a:r>
               <a:rPr lang="en-US" dirty="0"/>
-              <a:t>Tell participants: both disciplines return in 4.3, where each group tests its own Success in Practice.</a:t>
+              <a:t>Tell participants: both disciplines return in 4.3, where the worked example applies them, and in Section 5, where each group tests its own Success in Practice.</a:t>
             </a:r>
           </a:p>
           <a:p>
@@ -3186,13 +3186,13 @@
           <a:p>
             <a:r>
               <a:rPr lang="en-US" b="1" dirty="0"/>
-              <a:t>7. Link the domain to Section 4.</a:t>
-            </a:r>
-          </a:p>
-          <a:p>
-            <a:r>
-              <a:rPr lang="en-US" dirty="0"/>
-              <a:t>Say: "In Section 4 your group writes one Customer Experience &amp; Value statement. </a:t>
+              <a:t>7. Link the domain to Section 5.</a:t>
+            </a:r>
+          </a:p>
+          <a:p>
+            <a:r>
+              <a:rPr lang="en-US" dirty="0"/>
+              <a:t>Say: "In Section 5 your group writes one Customer Experience &amp; Value statement. </a:t>
             </a:r>
           </a:p>
           <a:p>
@@ -3321,10 +3321,10 @@
               <a:rPr lang="en-US" dirty="0"/>
               <a:t>
 Read the four outcomes aloud and say where the unit delivers each one.
-- Outcome 1 is built in Section 1 (the definition and its architecture) and produced in 4.1 and 4.2 (the Strategy Architecture and the Strategy Intent Statement).
-- Outcome 2 is built in 1.3 and Section 3 (the four SiP domains and their observable indicators) and produced in 4.3 (the four SiP statements).
-- Outcome 3 is tested in 4.1, where each group checks that its choices reinforce one another and reflect the realities of its capability and environment, and in 3.2, where the SiP Flammables test the balance of the picture of success.
-- Outcome 4 is built in Section 2 (the three functions the Strategy Intent and SiP serve) and applied in Section 5 (the contribution of each executive role).
+- Outcome 1 is built in Section 1 (the definition and its architecture) and shown in the 4.1 and 4.2 worked example and produced by each group in Section 5 (the Strategy Architecture and the Strategy Intent Statement).
+- Outcome 2 is built in 1.3 and Section 3 (the four SiP domains and their observable indicators) and shown in 4.3 and produced by each group in Section 5 (the four SiP statements).
+- Outcome 3 is tested through the six checks on the Architecture (4.1d), which each group applies to its own choices in Section 5, and in 3.2, where the SiP Flammables test the balance of the picture of success.
+- Outcome 4 is built in Section 2 (the three functions the Strategy Intent and SiP serve) and applied in Section 5, where the group builds one strategy for its company and every member agrees it.
 Each section slide carries that section’s two learning outcomes.
 </a:t>
             </a:r>
@@ -3810,13 +3810,13 @@
           <a:p>
             <a:r>
               <a:rPr lang="en-US" b="1" dirty="0"/>
-              <a:t>7. Link the domain to Section 4.</a:t>
-            </a:r>
-          </a:p>
-          <a:p>
-            <a:r>
-              <a:rPr lang="en-US" dirty="0"/>
-              <a:t>Say: "In Section 4 your group writes one Operational Capability &amp; Execution Rhythm statement. </a:t>
+              <a:t>7. Link the domain to Section 5.</a:t>
+            </a:r>
+          </a:p>
+          <a:p>
+            <a:r>
+              <a:rPr lang="en-US" dirty="0"/>
+              <a:t>Say: "In Section 5 your group writes one Operational Capability &amp; Execution Rhythm statement. </a:t>
             </a:r>
           </a:p>
           <a:p>
@@ -4344,7 +4344,7 @@
           <a:p>
             <a:r>
               <a:rPr lang="en-US" b="1" dirty="0"/>
-              <a:t>7. Link the domain to Section 4.</a:t>
+              <a:t>7. Link the domain to Section 5.</a:t>
             </a:r>
           </a:p>
           <a:p>
@@ -4354,7 +4354,7 @@
             </a:r>
             <a:r>
               <a:rPr lang="en-US" dirty="0"/>
-              <a:t>"In Section 4 your group writes one People &amp; Culture Dynamics statement. </a:t>
+              <a:t>"In Section 5 your group writes one People &amp; Culture Dynamics statement. </a:t>
             </a:r>
           </a:p>
           <a:p>
@@ -4862,7 +4862,7 @@
           <a:p>
             <a:r>
               <a:rPr lang="en-US" b="1" dirty="0"/>
-              <a:t>7. Link the domain to Section 4.</a:t>
+              <a:t>7. Link the domain to Section 5.</a:t>
             </a:r>
           </a:p>
           <a:p>
@@ -4872,7 +4872,7 @@
             </a:r>
             <a:r>
               <a:rPr lang="en-US" dirty="0"/>
-              <a:t>"In Section 4 your group writes one Enterprise Value Creation statement</a:t>
+              <a:t>"In Section 5 your group writes one Enterprise Value Creation statement</a:t>
             </a:r>
           </a:p>
           <a:p>
@@ -5515,7 +5515,7 @@
           <a:p>
             <a:r>
               <a:rPr lang="en-US" dirty="0"/>
-              <a:t>Say: "Every pattern grows from a legitimate perspective. We are here to see dominance early, while the SiP is still being written. </a:t>
+              <a:t>Say: "Every pattern grows from a legitimate perspective. We are here to see dominance early, while the SiP is still being written." </a:t>
             </a:r>
           </a:p>
         </p:txBody>
@@ -5727,7 +5727,7 @@
           <a:p>
             <a:r>
               <a:rPr lang="en-US" dirty="0"/>
-              <a:t>Note which domain is named most often. Tell the groups: test that domain hardest when you write your SiP in Section 4.</a:t>
+              <a:t>Note which domain is named most often. Tell the groups: test that domain hardest when you write your SiP in Section 5.</a:t>
             </a:r>
           </a:p>
           <a:p>
@@ -5748,7 +5748,7 @@
           <a:p>
             <a:r>
               <a:rPr lang="en-US" dirty="0"/>
-              <a:t>In Section 4 each group builds its own outputs and applies both tests to its Success in Practice."</a:t>
+              <a:t>Section 4 shows one company apply both tests to its Success in Practice. In Section 5 each group applies them to its own.""</a:t>
             </a:r>
           </a:p>
           <a:p>
@@ -7125,7 +7125,7 @@
               <a:rPr lang="en-US" dirty="0"/>
               <a:t>
 1. Walk the five sections in one sentence each, using the list below.
-2. Say plainly that Sections 1 to 3 prepare the thinking and Section 4 is where each group produces its three outputs. </a:t>
+2. Say plainly that Sections 1 to 3 prepare the thinking, Section 4 shows the three outputs completed once for one company, and Section 5 is where each group produces its own three outputs. </a:t>
             </a:r>
           </a:p>
           <a:p>
@@ -7168,14 +7168,14 @@
             <a:r>
               <a:rPr lang="en-US" dirty="0"/>
               <a:t>
-- Section 4 · Integration — Collective: each group builds its Strategy Architecture, derives its Strategy Intent Statement and builds its Success in Practice.</a:t>
+- Section 4 · Integration — Collective: one worked example, Kestrel Point Services, taken through the Strategy Architecture, the Strategy Intent Statement and Success in Practice.</a:t>
             </a:r>
           </a:p>
           <a:p>
             <a:r>
               <a:rPr lang="en-US" dirty="0"/>
               <a:t>
-- Section 5 · Application — In Practice: each participant applies the agreed Success in Practice to an executive role; the groups then share.
+- Section 5 · Application — In Practice: each group builds the Strategy Architecture, the Strategy Intent Statement and the Success in Practice of its simulated company, and every member agrees the group record. This is Capstone work.
 </a:t>
             </a:r>
           </a:p>
@@ -8130,7 +8130,7 @@
             </a:r>
             <a:r>
               <a:rPr/>
-              <a:t>"Step 1: answer the questions of each element and write what the element is saying. When all 14 are written, the scribe brings them together under the five headings, and your group edits the text until it says what you intend.</a:t>
+              <a:t>"Step 1: answer the questions of each element and write what the element is saying. When all 14 are written, the scribe selects Bring the 14 elements together, they appear under the five headings, and your group edits the text until it says what you intend.</a:t>
             </a:r>
           </a:p>
           <a:p>
@@ -8192,6 +8192,45 @@
           <a:p>
             <a:r>
               <a:t>The group chooses its scribe in 5.1 of the participant file and builds the three steps. Each member reads the Group record and selects Agree. The three outputs feed boxes 2A to 2F of the team's Capstone S2R Blueprint.</a:t>
+            </a:r>
+          </a:p>
+          <a:p>
+            <a:endParaRPr lang="en-GB" dirty="0"/>
+          </a:p>
+          <a:p>
+            <a:r>
+              <a:rPr lang="en-GB" dirty="0" b="1"/>
+              <a:t>LATER, WHEN THE GROUPS DO THE WORK ON THE PORTAL:</a:t>
+            </a:r>
+          </a:p>
+          <a:p>
+            <a:r>
+              <a:rPr lang="en-GB" dirty="0"/>
+              <a:t>Your role is to guide how the work is completed. This is Capstone work and is assessed independently at the capstone.</a:t>
+            </a:r>
+          </a:p>
+          <a:p>
+            <a:r>
+              <a:rPr lang="en-GB" dirty="0"/>
+              <a:t>Step 1 · Strategy Architecture. Remind the group that the elements are interconnected, and that each element is answered with actual strategic choices. When all 14 are written, the six checks beside the Architecture box guide the group's reading: "What is this architecture collectively saying about our company's strategy?"</a:t>
+            </a:r>
+          </a:p>
+          <a:p>
+            <a:r>
+              <a:rPr lang="en-GB" dirty="0"/>
+              <a:t>Step 2 · Strategy Intent Statement. The group condenses the Architecture into one clear statement. Say: "The Architecture contains the depth. The Intent must provide the clarity." Where the statement exposes a contradiction, the group resolves it in the Architecture before finalising the Intent.</a:t>
+            </a:r>
+          </a:p>
+          <a:p>
+            <a:r>
+              <a:rPr lang="en-GB" dirty="0"/>
+              <a:t>Step 3 · Success in Practice. The group describes observable reality: what people see and experience when the strategy works. Ask: "What is happening when the strategy is working?" The observable indicators from Section 3 deepen the discussion, and the SiP Flammables are the final balance check, so that each domain has its place in the picture of success.</a:t>
+            </a:r>
+          </a:p>
+          <a:p>
+            <a:r>
+              <a:rPr lang="en-GB" dirty="0"/>
+              <a:t>Group record. Each member reads the full record and selects Agree on their own page. When every member has agreed, the group can print the three outputs as one report: Strategy Architecture → Strategy Intent → Success in Practice.</a:t>
             </a:r>
           </a:p>
         </p:txBody>
@@ -8727,7 +8766,7 @@
           <a:p/>
           <a:p>
             <a:r>
-              <a:t>Unit 3 maps that Success in Practice and defines the Objective Key Results that will measure our progress toward it."</a:t>
+              <a:t>Unit 3 maps that Success in Practice and defines the Objectives and Key Results that will measure our progress towards it."</a:t>
             </a:r>
           </a:p>
           <a:p/>
@@ -9402,7 +9441,7 @@
           <a:p>
             <a:r>
               <a:rPr lang="en-US" b="1" dirty="0"/>
-              <a:t>9. Bridge to the next slide.</a:t>
+              <a:t>6. Bridge to the next slide.</a:t>
             </a:r>
           </a:p>
           <a:p>
@@ -9754,7 +9793,7 @@
           <a:p>
             <a:r>
               <a:rPr lang="en-ZA" dirty="0"/>
-              <a:t>The signals that photography was moving toward digital were therefore not entirely external to the company.</a:t>
+              <a:t>The signals that photography was moving towards digital were therefore not entirely external to the company.</a:t>
             </a:r>
           </a:p>
           <a:p>
@@ -10601,7 +10640,7 @@
           <a:p>
             <a:r>
               <a:rPr lang="en-US" dirty="0"/>
-              <a:t>Take three or four answers and note them. They show where each group will need to work hardest in Section 4.</a:t>
+              <a:t>Take three or four answers and note them. They show where each group will need to work hardest in Section 5.</a:t>
             </a:r>
           </a:p>
           <a:p>
@@ -10622,7 +10661,7 @@
           <a:p>
             <a:r>
               <a:rPr lang="en-US" dirty="0"/>
-              <a:t>In Section 4 each group works this definition as 14 elements. </a:t>
+              <a:t>In Section 4 you see this definition worked as 14 elements for one company, and in Section 5 your group works it for its own company." </a:t>
             </a:r>
           </a:p>
           <a:p>
@@ -11387,7 +11426,7 @@
           <a:p>
             <a:r>
               <a:rPr lang="en-US" dirty="0"/>
-              <a:t>Ask participants to describe the observable organisational reality. Each group writes its own Strategy Intent Statement in Section 4.</a:t>
+              <a:t>Ask participants to describe the observable organisational reality. Each group writes its own Strategy Intent Statement in Section 5.</a:t>
             </a:r>
           </a:p>
           <a:p>
@@ -11507,11 +11546,11 @@
           <a:p>
             <a:r>
               <a:rPr lang="en-US" b="1" dirty="0"/>
-              <a:t>Say</a:t>
-            </a:r>
-            <a:r>
-              <a:rPr lang="en-US" dirty="0"/>
-              <a:t> Before you build, know exactly what you are building toward and why each element matters."</a:t>
+              <a:t>Say: </a:t>
+            </a:r>
+            <a:r>
+              <a:rPr lang="en-US" dirty="0"/>
+              <a:t>"Before you build, know exactly what you are building towards and why each element matters."</a:t>
             </a:r>
           </a:p>
           <a:p>

</xml_diff>